<commit_message>
rupac25 + dissertation update
</commit_message>
<xml_diff>
--- a/2025/4. Публикация Nuclotron/vector diagram.pptx
+++ b/2025/4. Публикация Nuclotron/vector diagram.pptx
@@ -262,7 +262,7 @@
           <a:p>
             <a:fld id="{88D44FA9-5D69-46DD-BB4A-8A959C93BCF9}" type="datetimeFigureOut">
               <a:rPr lang="ru-RU" smtClean="0"/>
-              <a:t>04.08.2025</a:t>
+              <a:t>14.08.2025</a:t>
             </a:fld>
             <a:endParaRPr lang="ru-RU"/>
           </a:p>
@@ -460,7 +460,7 @@
           <a:p>
             <a:fld id="{88D44FA9-5D69-46DD-BB4A-8A959C93BCF9}" type="datetimeFigureOut">
               <a:rPr lang="ru-RU" smtClean="0"/>
-              <a:t>04.08.2025</a:t>
+              <a:t>14.08.2025</a:t>
             </a:fld>
             <a:endParaRPr lang="ru-RU"/>
           </a:p>
@@ -668,7 +668,7 @@
           <a:p>
             <a:fld id="{88D44FA9-5D69-46DD-BB4A-8A959C93BCF9}" type="datetimeFigureOut">
               <a:rPr lang="ru-RU" smtClean="0"/>
-              <a:t>04.08.2025</a:t>
+              <a:t>14.08.2025</a:t>
             </a:fld>
             <a:endParaRPr lang="ru-RU"/>
           </a:p>
@@ -866,7 +866,7 @@
           <a:p>
             <a:fld id="{88D44FA9-5D69-46DD-BB4A-8A959C93BCF9}" type="datetimeFigureOut">
               <a:rPr lang="ru-RU" smtClean="0"/>
-              <a:t>04.08.2025</a:t>
+              <a:t>14.08.2025</a:t>
             </a:fld>
             <a:endParaRPr lang="ru-RU"/>
           </a:p>
@@ -1141,7 +1141,7 @@
           <a:p>
             <a:fld id="{88D44FA9-5D69-46DD-BB4A-8A959C93BCF9}" type="datetimeFigureOut">
               <a:rPr lang="ru-RU" smtClean="0"/>
-              <a:t>04.08.2025</a:t>
+              <a:t>14.08.2025</a:t>
             </a:fld>
             <a:endParaRPr lang="ru-RU"/>
           </a:p>
@@ -1406,7 +1406,7 @@
           <a:p>
             <a:fld id="{88D44FA9-5D69-46DD-BB4A-8A959C93BCF9}" type="datetimeFigureOut">
               <a:rPr lang="ru-RU" smtClean="0"/>
-              <a:t>04.08.2025</a:t>
+              <a:t>14.08.2025</a:t>
             </a:fld>
             <a:endParaRPr lang="ru-RU"/>
           </a:p>
@@ -1818,7 +1818,7 @@
           <a:p>
             <a:fld id="{88D44FA9-5D69-46DD-BB4A-8A959C93BCF9}" type="datetimeFigureOut">
               <a:rPr lang="ru-RU" smtClean="0"/>
-              <a:t>04.08.2025</a:t>
+              <a:t>14.08.2025</a:t>
             </a:fld>
             <a:endParaRPr lang="ru-RU"/>
           </a:p>
@@ -1959,7 +1959,7 @@
           <a:p>
             <a:fld id="{88D44FA9-5D69-46DD-BB4A-8A959C93BCF9}" type="datetimeFigureOut">
               <a:rPr lang="ru-RU" smtClean="0"/>
-              <a:t>04.08.2025</a:t>
+              <a:t>14.08.2025</a:t>
             </a:fld>
             <a:endParaRPr lang="ru-RU"/>
           </a:p>
@@ -2072,7 +2072,7 @@
           <a:p>
             <a:fld id="{88D44FA9-5D69-46DD-BB4A-8A959C93BCF9}" type="datetimeFigureOut">
               <a:rPr lang="ru-RU" smtClean="0"/>
-              <a:t>04.08.2025</a:t>
+              <a:t>14.08.2025</a:t>
             </a:fld>
             <a:endParaRPr lang="ru-RU"/>
           </a:p>
@@ -2383,7 +2383,7 @@
           <a:p>
             <a:fld id="{88D44FA9-5D69-46DD-BB4A-8A959C93BCF9}" type="datetimeFigureOut">
               <a:rPr lang="ru-RU" smtClean="0"/>
-              <a:t>04.08.2025</a:t>
+              <a:t>14.08.2025</a:t>
             </a:fld>
             <a:endParaRPr lang="ru-RU"/>
           </a:p>
@@ -2671,7 +2671,7 @@
           <a:p>
             <a:fld id="{88D44FA9-5D69-46DD-BB4A-8A959C93BCF9}" type="datetimeFigureOut">
               <a:rPr lang="ru-RU" smtClean="0"/>
-              <a:t>04.08.2025</a:t>
+              <a:t>14.08.2025</a:t>
             </a:fld>
             <a:endParaRPr lang="ru-RU"/>
           </a:p>
@@ -2912,7 +2912,7 @@
           <a:p>
             <a:fld id="{88D44FA9-5D69-46DD-BB4A-8A959C93BCF9}" type="datetimeFigureOut">
               <a:rPr lang="ru-RU" smtClean="0"/>
-              <a:t>04.08.2025</a:t>
+              <a:t>14.08.2025</a:t>
             </a:fld>
             <a:endParaRPr lang="ru-RU"/>
           </a:p>
@@ -4062,8 +4062,8 @@
           </a:fontRef>
         </p:style>
       </p:cxnSp>
-      <mc:AlternateContent xmlns:mc="http://schemas.openxmlformats.org/markup-compatibility/2006">
-        <mc:Choice xmlns:a14="http://schemas.microsoft.com/office/drawing/2010/main" Requires="a14">
+      <mc:AlternateContent xmlns:mc="http://schemas.openxmlformats.org/markup-compatibility/2006" xmlns:a14="http://schemas.microsoft.com/office/drawing/2010/main">
+        <mc:Choice Requires="a14">
           <p:sp>
             <p:nvSpPr>
               <p:cNvPr id="41" name="TextBox 40">
@@ -4092,6 +4092,7 @@
               </a:bodyPr>
               <a:lstStyle/>
               <a:p>
+                <a:pPr/>
                 <a14:m>
                   <m:oMathPara xmlns:m="http://schemas.openxmlformats.org/officeDocument/2006/math">
                     <m:oMathParaPr>
@@ -4162,7 +4163,7 @@
             </p:txBody>
           </p:sp>
         </mc:Choice>
-        <mc:Fallback>
+        <mc:Fallback xmlns="">
           <p:sp>
             <p:nvSpPr>
               <p:cNvPr id="41" name="TextBox 40">
@@ -4295,8 +4296,8 @@
           </a:fontRef>
         </p:style>
       </p:cxnSp>
-      <mc:AlternateContent xmlns:mc="http://schemas.openxmlformats.org/markup-compatibility/2006">
-        <mc:Choice xmlns:a14="http://schemas.microsoft.com/office/drawing/2010/main" Requires="a14">
+      <mc:AlternateContent xmlns:mc="http://schemas.openxmlformats.org/markup-compatibility/2006" xmlns:a14="http://schemas.microsoft.com/office/drawing/2010/main">
+        <mc:Choice Requires="a14">
           <p:sp>
             <p:nvSpPr>
               <p:cNvPr id="51" name="TextBox 50">
@@ -4325,6 +4326,7 @@
               </a:bodyPr>
               <a:lstStyle/>
               <a:p>
+                <a:pPr/>
                 <a14:m>
                   <m:oMathPara xmlns:m="http://schemas.openxmlformats.org/officeDocument/2006/math">
                     <m:oMathParaPr>
@@ -4363,7 +4365,7 @@
             </p:txBody>
           </p:sp>
         </mc:Choice>
-        <mc:Fallback>
+        <mc:Fallback xmlns="">
           <p:sp>
             <p:nvSpPr>
               <p:cNvPr id="51" name="TextBox 50">
@@ -4408,8 +4410,8 @@
           </p:sp>
         </mc:Fallback>
       </mc:AlternateContent>
-      <mc:AlternateContent xmlns:mc="http://schemas.openxmlformats.org/markup-compatibility/2006">
-        <mc:Choice xmlns:a14="http://schemas.microsoft.com/office/drawing/2010/main" Requires="a14">
+      <mc:AlternateContent xmlns:mc="http://schemas.openxmlformats.org/markup-compatibility/2006" xmlns:a14="http://schemas.microsoft.com/office/drawing/2010/main">
+        <mc:Choice Requires="a14">
           <p:sp>
             <p:nvSpPr>
               <p:cNvPr id="53" name="TextBox 52">
@@ -4467,7 +4469,7 @@
             </p:txBody>
           </p:sp>
         </mc:Choice>
-        <mc:Fallback>
+        <mc:Fallback xmlns="">
           <p:sp>
             <p:nvSpPr>
               <p:cNvPr id="53" name="TextBox 52">
@@ -4548,8 +4550,8 @@
           </a:p>
         </p:txBody>
       </p:sp>
-      <mc:AlternateContent xmlns:mc="http://schemas.openxmlformats.org/markup-compatibility/2006">
-        <mc:Choice xmlns:a14="http://schemas.microsoft.com/office/drawing/2010/main" Requires="a14">
+      <mc:AlternateContent xmlns:mc="http://schemas.openxmlformats.org/markup-compatibility/2006" xmlns:a14="http://schemas.microsoft.com/office/drawing/2010/main">
+        <mc:Choice Requires="a14">
           <p:sp>
             <p:nvSpPr>
               <p:cNvPr id="56" name="TextBox 55">
@@ -4730,7 +4732,7 @@
             </p:txBody>
           </p:sp>
         </mc:Choice>
-        <mc:Fallback>
+        <mc:Fallback xmlns="">
           <p:sp>
             <p:nvSpPr>
               <p:cNvPr id="56" name="TextBox 55">
@@ -4792,7 +4794,7 @@
             <p:spPr>
               <a:xfrm>
                 <a:off x="98727" y="1160601"/>
-                <a:ext cx="1129618" cy="356893"/>
+                <a:ext cx="1368768" cy="356893"/>
               </a:xfrm>
               <a:prstGeom prst="rect">
                 <a:avLst/>
@@ -4986,7 +4988,7 @@
             <p:spPr>
               <a:xfrm>
                 <a:off x="98727" y="1160601"/>
-                <a:ext cx="1129618" cy="356893"/>
+                <a:ext cx="1368768" cy="356893"/>
               </a:xfrm>
               <a:prstGeom prst="rect">
                 <a:avLst/>
@@ -4994,7 +4996,7 @@
               <a:blipFill>
                 <a:blip r:embed="rId6"/>
                 <a:stretch>
-                  <a:fillRect t="-3448" b="-6897"/>
+                  <a:fillRect t="-8475" r="-4889"/>
                 </a:stretch>
               </a:blipFill>
             </p:spPr>
@@ -5013,8 +5015,8 @@
           </p:sp>
         </mc:Fallback>
       </mc:AlternateContent>
-      <mc:AlternateContent xmlns:mc="http://schemas.openxmlformats.org/markup-compatibility/2006">
-        <mc:Choice xmlns:a14="http://schemas.microsoft.com/office/drawing/2010/main" Requires="a14">
+      <mc:AlternateContent xmlns:mc="http://schemas.openxmlformats.org/markup-compatibility/2006" xmlns:a14="http://schemas.microsoft.com/office/drawing/2010/main">
+        <mc:Choice Requires="a14">
           <p:sp>
             <p:nvSpPr>
               <p:cNvPr id="65" name="TextBox 64">
@@ -5243,18 +5245,24 @@
                       <m:f>
                         <m:fPr>
                           <m:ctrlPr>
-                            <a:rPr lang="ru-RU" sz="1400" i="1"/>
+                            <a:rPr lang="ru-RU" sz="1400" i="1">
+                              <a:latin typeface="Cambria Math" panose="02040503050406030204" pitchFamily="18" charset="0"/>
+                            </a:rPr>
                           </m:ctrlPr>
                         </m:fPr>
                         <m:num>
                           <m:r>
-                            <a:rPr lang="en-US" sz="1400" i="1"/>
+                            <a:rPr lang="en-US" sz="1400" i="1">
+                              <a:latin typeface="Cambria Math" panose="02040503050406030204" pitchFamily="18" charset="0"/>
+                            </a:rPr>
                             <m:t>𝑞</m:t>
                           </m:r>
                         </m:num>
                         <m:den>
                           <m:r>
-                            <a:rPr lang="en-US" sz="1400" i="1"/>
+                            <a:rPr lang="en-US" sz="1400" i="1">
+                              <a:latin typeface="Cambria Math" panose="02040503050406030204" pitchFamily="18" charset="0"/>
+                            </a:rPr>
                             <m:t>𝑚</m:t>
                           </m:r>
                           <m:r>
@@ -5268,7 +5276,9 @@
                       <m:sSub>
                         <m:sSubPr>
                           <m:ctrlPr>
-                            <a:rPr lang="ru-RU" sz="1400" i="1"/>
+                            <a:rPr lang="ru-RU" sz="1400" i="1">
+                              <a:latin typeface="Cambria Math" panose="02040503050406030204" pitchFamily="18" charset="0"/>
+                            </a:rPr>
                           </m:ctrlPr>
                         </m:sSubPr>
                         <m:e>
@@ -5279,19 +5289,25 @@
                             <m:t>𝛾</m:t>
                           </m:r>
                           <m:r>
-                            <a:rPr lang="en-US" sz="1400" i="1"/>
+                            <a:rPr lang="en-US" sz="1400" i="1">
+                              <a:latin typeface="Cambria Math" panose="02040503050406030204" pitchFamily="18" charset="0"/>
+                            </a:rPr>
                             <m:t>𝐺</m:t>
                           </m:r>
                           <m:acc>
                             <m:accPr>
                               <m:chr m:val="⃗"/>
                               <m:ctrlPr>
-                                <a:rPr lang="ru-RU" sz="1400" i="1"/>
+                                <a:rPr lang="ru-RU" sz="1400" i="1">
+                                  <a:latin typeface="Cambria Math" panose="02040503050406030204" pitchFamily="18" charset="0"/>
+                                </a:rPr>
                               </m:ctrlPr>
                             </m:accPr>
                             <m:e>
                               <m:r>
-                                <a:rPr lang="en-US" sz="1400" i="1"/>
+                                <a:rPr lang="en-US" sz="1400" i="1">
+                                  <a:latin typeface="Cambria Math" panose="02040503050406030204" pitchFamily="18" charset="0"/>
+                                </a:rPr>
                                 <m:t>𝐵</m:t>
                               </m:r>
                             </m:e>
@@ -5299,7 +5315,9 @@
                         </m:e>
                         <m:sub>
                           <m:r>
-                            <a:rPr lang="en-US" sz="1400" i="1"/>
+                            <a:rPr lang="en-US" sz="1400" i="1">
+                              <a:latin typeface="Cambria Math" panose="02040503050406030204" pitchFamily="18" charset="0"/>
+                            </a:rPr>
                             <m:t>⊥</m:t>
                           </m:r>
                         </m:sub>
@@ -5312,7 +5330,7 @@
             </p:txBody>
           </p:sp>
         </mc:Choice>
-        <mc:Fallback>
+        <mc:Fallback xmlns="">
           <p:sp>
             <p:nvSpPr>
               <p:cNvPr id="65" name="TextBox 64">
@@ -5357,8 +5375,8 @@
           </p:sp>
         </mc:Fallback>
       </mc:AlternateContent>
-      <mc:AlternateContent xmlns:mc="http://schemas.openxmlformats.org/markup-compatibility/2006">
-        <mc:Choice xmlns:a14="http://schemas.microsoft.com/office/drawing/2010/main" Requires="a14">
+      <mc:AlternateContent xmlns:mc="http://schemas.openxmlformats.org/markup-compatibility/2006" xmlns:a14="http://schemas.microsoft.com/office/drawing/2010/main">
+        <mc:Choice Requires="a14">
           <p:sp>
             <p:nvSpPr>
               <p:cNvPr id="66" name="TextBox 65">
@@ -5387,6 +5405,7 @@
               </a:bodyPr>
               <a:lstStyle/>
               <a:p>
+                <a:pPr/>
                 <a14:m>
                   <m:oMathPara xmlns:m="http://schemas.openxmlformats.org/officeDocument/2006/math">
                     <m:oMathParaPr>
@@ -5425,7 +5444,7 @@
             </p:txBody>
           </p:sp>
         </mc:Choice>
-        <mc:Fallback>
+        <mc:Fallback xmlns="">
           <p:sp>
             <p:nvSpPr>
               <p:cNvPr id="66" name="TextBox 65">
@@ -5470,8 +5489,8 @@
           </p:sp>
         </mc:Fallback>
       </mc:AlternateContent>
-      <mc:AlternateContent xmlns:mc="http://schemas.openxmlformats.org/markup-compatibility/2006">
-        <mc:Choice xmlns:a14="http://schemas.microsoft.com/office/drawing/2010/main" Requires="a14">
+      <mc:AlternateContent xmlns:mc="http://schemas.openxmlformats.org/markup-compatibility/2006" xmlns:a14="http://schemas.microsoft.com/office/drawing/2010/main">
+        <mc:Choice Requires="a14">
           <p:sp>
             <p:nvSpPr>
               <p:cNvPr id="67" name="TextBox 66">
@@ -5500,6 +5519,7 @@
               </a:bodyPr>
               <a:lstStyle/>
               <a:p>
+                <a:pPr/>
                 <a14:m>
                   <m:oMathPara xmlns:m="http://schemas.openxmlformats.org/officeDocument/2006/math">
                     <m:oMathParaPr>
@@ -5542,7 +5562,7 @@
             </p:txBody>
           </p:sp>
         </mc:Choice>
-        <mc:Fallback>
+        <mc:Fallback xmlns="">
           <p:sp>
             <p:nvSpPr>
               <p:cNvPr id="67" name="TextBox 66">
@@ -5587,8 +5607,8 @@
           </p:sp>
         </mc:Fallback>
       </mc:AlternateContent>
-      <mc:AlternateContent xmlns:mc="http://schemas.openxmlformats.org/markup-compatibility/2006">
-        <mc:Choice xmlns:a14="http://schemas.microsoft.com/office/drawing/2010/main" Requires="a14">
+      <mc:AlternateContent xmlns:mc="http://schemas.openxmlformats.org/markup-compatibility/2006" xmlns:a14="http://schemas.microsoft.com/office/drawing/2010/main">
+        <mc:Choice Requires="a14">
           <p:sp>
             <p:nvSpPr>
               <p:cNvPr id="68" name="TextBox 67">
@@ -5617,6 +5637,7 @@
               </a:bodyPr>
               <a:lstStyle/>
               <a:p>
+                <a:pPr/>
                 <a14:m>
                   <m:oMathPara xmlns:m="http://schemas.openxmlformats.org/officeDocument/2006/math">
                     <m:oMathParaPr>
@@ -5655,7 +5676,7 @@
             </p:txBody>
           </p:sp>
         </mc:Choice>
-        <mc:Fallback>
+        <mc:Fallback xmlns="">
           <p:sp>
             <p:nvSpPr>
               <p:cNvPr id="68" name="TextBox 67">
@@ -5700,8 +5721,8 @@
           </p:sp>
         </mc:Fallback>
       </mc:AlternateContent>
-      <mc:AlternateContent xmlns:mc="http://schemas.openxmlformats.org/markup-compatibility/2006">
-        <mc:Choice xmlns:a14="http://schemas.microsoft.com/office/drawing/2010/main" Requires="a14">
+      <mc:AlternateContent xmlns:mc="http://schemas.openxmlformats.org/markup-compatibility/2006" xmlns:a14="http://schemas.microsoft.com/office/drawing/2010/main">
+        <mc:Choice Requires="a14">
           <p:sp>
             <p:nvSpPr>
               <p:cNvPr id="69" name="TextBox 68">
@@ -5730,6 +5751,7 @@
               </a:bodyPr>
               <a:lstStyle/>
               <a:p>
+                <a:pPr/>
                 <a14:m>
                   <m:oMathPara xmlns:m="http://schemas.openxmlformats.org/officeDocument/2006/math">
                     <m:oMathParaPr>
@@ -5772,7 +5794,7 @@
             </p:txBody>
           </p:sp>
         </mc:Choice>
-        <mc:Fallback>
+        <mc:Fallback xmlns="">
           <p:sp>
             <p:nvSpPr>
               <p:cNvPr id="69" name="TextBox 68">
@@ -5902,8 +5924,8 @@
           </a:fontRef>
         </p:style>
       </p:cxnSp>
-      <mc:AlternateContent xmlns:mc="http://schemas.openxmlformats.org/markup-compatibility/2006">
-        <mc:Choice xmlns:a14="http://schemas.microsoft.com/office/drawing/2010/main" Requires="a14">
+      <mc:AlternateContent xmlns:mc="http://schemas.openxmlformats.org/markup-compatibility/2006" xmlns:a14="http://schemas.microsoft.com/office/drawing/2010/main">
+        <mc:Choice Requires="a14">
           <p:sp>
             <p:nvSpPr>
               <p:cNvPr id="85" name="TextBox 84">
@@ -6014,7 +6036,7 @@
             </p:txBody>
           </p:sp>
         </mc:Choice>
-        <mc:Fallback>
+        <mc:Fallback xmlns="">
           <p:sp>
             <p:nvSpPr>
               <p:cNvPr id="85" name="TextBox 84">
@@ -6059,8 +6081,8 @@
           </p:sp>
         </mc:Fallback>
       </mc:AlternateContent>
-      <mc:AlternateContent xmlns:mc="http://schemas.openxmlformats.org/markup-compatibility/2006">
-        <mc:Choice xmlns:a14="http://schemas.microsoft.com/office/drawing/2010/main" Requires="a14">
+      <mc:AlternateContent xmlns:mc="http://schemas.openxmlformats.org/markup-compatibility/2006" xmlns:a14="http://schemas.microsoft.com/office/drawing/2010/main">
+        <mc:Choice Requires="a14">
           <p:sp>
             <p:nvSpPr>
               <p:cNvPr id="89" name="TextBox 88">
@@ -6089,7 +6111,6 @@
               </a:bodyPr>
               <a:lstStyle/>
               <a:p>
-                <a:pPr/>
                 <a14:m>
                   <m:oMath xmlns:m="http://schemas.openxmlformats.org/officeDocument/2006/math">
                     <m:sSubSup>
@@ -6522,7 +6543,7 @@
             </p:txBody>
           </p:sp>
         </mc:Choice>
-        <mc:Fallback>
+        <mc:Fallback xmlns="">
           <p:sp>
             <p:nvSpPr>
               <p:cNvPr id="89" name="TextBox 88">
@@ -6723,7 +6744,7 @@
             <p:spPr>
               <a:xfrm>
                 <a:off x="98726" y="2626168"/>
-                <a:ext cx="2168042" cy="552844"/>
+                <a:ext cx="2613994" cy="552844"/>
               </a:xfrm>
               <a:prstGeom prst="rect">
                 <a:avLst/>
@@ -6981,7 +7002,7 @@
             <p:spPr>
               <a:xfrm>
                 <a:off x="98726" y="2626168"/>
-                <a:ext cx="2168042" cy="552844"/>
+                <a:ext cx="2613994" cy="552844"/>
               </a:xfrm>
               <a:prstGeom prst="rect">
                 <a:avLst/>
@@ -6989,7 +7010,7 @@
               <a:blipFill>
                 <a:blip r:embed="rId14"/>
                 <a:stretch>
-                  <a:fillRect t="-4444" b="-2222"/>
+                  <a:fillRect/>
                 </a:stretch>
               </a:blipFill>
             </p:spPr>
@@ -7024,8 +7045,8 @@
             </p:nvSpPr>
             <p:spPr>
               <a:xfrm>
-                <a:off x="102080" y="3216536"/>
-                <a:ext cx="3994535" cy="651076"/>
+                <a:off x="18653" y="3254279"/>
+                <a:ext cx="4163667" cy="651076"/>
               </a:xfrm>
               <a:prstGeom prst="rect">
                 <a:avLst/>
@@ -7392,8 +7413,8 @@
             </p:nvSpPr>
             <p:spPr>
               <a:xfrm>
-                <a:off x="102080" y="3216536"/>
-                <a:ext cx="3994535" cy="651076"/>
+                <a:off x="18653" y="3254279"/>
+                <a:ext cx="4163667" cy="651076"/>
               </a:xfrm>
               <a:prstGeom prst="rect">
                 <a:avLst/>
@@ -7401,7 +7422,7 @@
               <a:blipFill>
                 <a:blip r:embed="rId15"/>
                 <a:stretch>
-                  <a:fillRect t="-1923"/>
+                  <a:fillRect/>
                 </a:stretch>
               </a:blipFill>
             </p:spPr>
@@ -7508,8 +7529,8 @@
           </a:fontRef>
         </p:style>
       </p:cxnSp>
-      <mc:AlternateContent xmlns:mc="http://schemas.openxmlformats.org/markup-compatibility/2006">
-        <mc:Choice xmlns:a14="http://schemas.microsoft.com/office/drawing/2010/main" Requires="a14">
+      <mc:AlternateContent xmlns:mc="http://schemas.openxmlformats.org/markup-compatibility/2006" xmlns:a14="http://schemas.microsoft.com/office/drawing/2010/main">
+        <mc:Choice Requires="a14">
           <p:sp>
             <p:nvSpPr>
               <p:cNvPr id="108" name="TextBox 107">
@@ -7577,7 +7598,7 @@
             </p:txBody>
           </p:sp>
         </mc:Choice>
-        <mc:Fallback>
+        <mc:Fallback xmlns="">
           <p:sp>
             <p:nvSpPr>
               <p:cNvPr id="108" name="TextBox 107">
@@ -7622,8 +7643,8 @@
           </p:sp>
         </mc:Fallback>
       </mc:AlternateContent>
-      <mc:AlternateContent xmlns:mc="http://schemas.openxmlformats.org/markup-compatibility/2006">
-        <mc:Choice xmlns:a14="http://schemas.microsoft.com/office/drawing/2010/main" Requires="a14">
+      <mc:AlternateContent xmlns:mc="http://schemas.openxmlformats.org/markup-compatibility/2006" xmlns:a14="http://schemas.microsoft.com/office/drawing/2010/main">
+        <mc:Choice Requires="a14">
           <p:sp>
             <p:nvSpPr>
               <p:cNvPr id="110" name="TextBox 109">
@@ -7652,7 +7673,6 @@
               </a:bodyPr>
               <a:lstStyle/>
               <a:p>
-                <a:pPr/>
                 <a14:m>
                   <m:oMath xmlns:m="http://schemas.openxmlformats.org/officeDocument/2006/math">
                     <m:sSubSup>
@@ -7950,7 +7970,7 @@
             </p:txBody>
           </p:sp>
         </mc:Choice>
-        <mc:Fallback>
+        <mc:Fallback xmlns="">
           <p:sp>
             <p:nvSpPr>
               <p:cNvPr id="110" name="TextBox 109">
@@ -8143,8 +8163,8 @@
           </a:fontRef>
         </p:style>
       </p:cxnSp>
-      <mc:AlternateContent xmlns:mc="http://schemas.openxmlformats.org/markup-compatibility/2006">
-        <mc:Choice xmlns:a14="http://schemas.microsoft.com/office/drawing/2010/main" Requires="a14">
+      <mc:AlternateContent xmlns:mc="http://schemas.openxmlformats.org/markup-compatibility/2006" xmlns:a14="http://schemas.microsoft.com/office/drawing/2010/main">
+        <mc:Choice Requires="a14">
           <p:sp>
             <p:nvSpPr>
               <p:cNvPr id="116" name="TextBox 115">
@@ -8244,7 +8264,7 @@
             </p:txBody>
           </p:sp>
         </mc:Choice>
-        <mc:Fallback>
+        <mc:Fallback xmlns="">
           <p:sp>
             <p:nvSpPr>
               <p:cNvPr id="116" name="TextBox 115">
@@ -8374,8 +8394,8 @@
           </a:fontRef>
         </p:style>
       </p:cxnSp>
-      <mc:AlternateContent xmlns:mc="http://schemas.openxmlformats.org/markup-compatibility/2006">
-        <mc:Choice xmlns:a14="http://schemas.microsoft.com/office/drawing/2010/main" Requires="a14">
+      <mc:AlternateContent xmlns:mc="http://schemas.openxmlformats.org/markup-compatibility/2006" xmlns:a14="http://schemas.microsoft.com/office/drawing/2010/main">
+        <mc:Choice Requires="a14">
           <p:sp>
             <p:nvSpPr>
               <p:cNvPr id="126" name="TextBox 125">
@@ -8404,6 +8424,7 @@
               </a:bodyPr>
               <a:lstStyle/>
               <a:p>
+                <a:pPr/>
                 <a14:m>
                   <m:oMathPara xmlns:m="http://schemas.openxmlformats.org/officeDocument/2006/math">
                     <m:oMathParaPr>
@@ -8442,7 +8463,7 @@
             </p:txBody>
           </p:sp>
         </mc:Choice>
-        <mc:Fallback>
+        <mc:Fallback xmlns="">
           <p:sp>
             <p:nvSpPr>
               <p:cNvPr id="126" name="TextBox 125">
@@ -8487,8 +8508,8 @@
           </p:sp>
         </mc:Fallback>
       </mc:AlternateContent>
-      <mc:AlternateContent xmlns:mc="http://schemas.openxmlformats.org/markup-compatibility/2006">
-        <mc:Choice xmlns:a14="http://schemas.microsoft.com/office/drawing/2010/main" Requires="a14">
+      <mc:AlternateContent xmlns:mc="http://schemas.openxmlformats.org/markup-compatibility/2006" xmlns:a14="http://schemas.microsoft.com/office/drawing/2010/main">
+        <mc:Choice Requires="a14">
           <p:sp>
             <p:nvSpPr>
               <p:cNvPr id="127" name="TextBox 126">
@@ -8517,6 +8538,7 @@
               </a:bodyPr>
               <a:lstStyle/>
               <a:p>
+                <a:pPr/>
                 <a14:m>
                   <m:oMathPara xmlns:m="http://schemas.openxmlformats.org/officeDocument/2006/math">
                     <m:oMathParaPr>
@@ -8559,7 +8581,7 @@
             </p:txBody>
           </p:sp>
         </mc:Choice>
-        <mc:Fallback>
+        <mc:Fallback xmlns="">
           <p:sp>
             <p:nvSpPr>
               <p:cNvPr id="127" name="TextBox 126">
@@ -8604,8 +8626,8 @@
           </p:sp>
         </mc:Fallback>
       </mc:AlternateContent>
-      <mc:AlternateContent xmlns:mc="http://schemas.openxmlformats.org/markup-compatibility/2006">
-        <mc:Choice xmlns:a14="http://schemas.microsoft.com/office/drawing/2010/main" Requires="a14">
+      <mc:AlternateContent xmlns:mc="http://schemas.openxmlformats.org/markup-compatibility/2006" xmlns:a14="http://schemas.microsoft.com/office/drawing/2010/main">
+        <mc:Choice Requires="a14">
           <p:sp>
             <p:nvSpPr>
               <p:cNvPr id="130" name="TextBox 129">
@@ -8634,7 +8656,6 @@
               </a:bodyPr>
               <a:lstStyle/>
               <a:p>
-                <a:pPr/>
                 <a14:m>
                   <m:oMath xmlns:m="http://schemas.openxmlformats.org/officeDocument/2006/math">
                     <m:sSubSup>
@@ -8874,7 +8895,7 @@
             </p:txBody>
           </p:sp>
         </mc:Choice>
-        <mc:Fallback>
+        <mc:Fallback xmlns="">
           <p:sp>
             <p:nvSpPr>
               <p:cNvPr id="130" name="TextBox 129">
@@ -9802,8 +9823,8 @@
           </a:fontRef>
         </p:style>
       </p:cxnSp>
-      <mc:AlternateContent xmlns:mc="http://schemas.openxmlformats.org/markup-compatibility/2006">
-        <mc:Choice xmlns:a14="http://schemas.microsoft.com/office/drawing/2010/main" Requires="a14">
+      <mc:AlternateContent xmlns:mc="http://schemas.openxmlformats.org/markup-compatibility/2006" xmlns:a14="http://schemas.microsoft.com/office/drawing/2010/main">
+        <mc:Choice Requires="a14">
           <p:sp>
             <p:nvSpPr>
               <p:cNvPr id="41" name="TextBox 40">
@@ -9903,7 +9924,7 @@
             </p:txBody>
           </p:sp>
         </mc:Choice>
-        <mc:Fallback>
+        <mc:Fallback xmlns="">
           <p:sp>
             <p:nvSpPr>
               <p:cNvPr id="41" name="TextBox 40">
@@ -10036,8 +10057,8 @@
           </a:fontRef>
         </p:style>
       </p:cxnSp>
-      <mc:AlternateContent xmlns:mc="http://schemas.openxmlformats.org/markup-compatibility/2006">
-        <mc:Choice xmlns:a14="http://schemas.microsoft.com/office/drawing/2010/main" Requires="a14">
+      <mc:AlternateContent xmlns:mc="http://schemas.openxmlformats.org/markup-compatibility/2006" xmlns:a14="http://schemas.microsoft.com/office/drawing/2010/main">
+        <mc:Choice Requires="a14">
           <p:sp>
             <p:nvSpPr>
               <p:cNvPr id="51" name="TextBox 50">
@@ -10105,7 +10126,7 @@
             </p:txBody>
           </p:sp>
         </mc:Choice>
-        <mc:Fallback>
+        <mc:Fallback xmlns="">
           <p:sp>
             <p:nvSpPr>
               <p:cNvPr id="51" name="TextBox 50">
@@ -10150,8 +10171,8 @@
           </p:sp>
         </mc:Fallback>
       </mc:AlternateContent>
-      <mc:AlternateContent xmlns:mc="http://schemas.openxmlformats.org/markup-compatibility/2006">
-        <mc:Choice xmlns:a14="http://schemas.microsoft.com/office/drawing/2010/main" Requires="a14">
+      <mc:AlternateContent xmlns:mc="http://schemas.openxmlformats.org/markup-compatibility/2006" xmlns:a14="http://schemas.microsoft.com/office/drawing/2010/main">
+        <mc:Choice Requires="a14">
           <p:sp>
             <p:nvSpPr>
               <p:cNvPr id="53" name="TextBox 52">
@@ -10211,7 +10232,7 @@
             </p:txBody>
           </p:sp>
         </mc:Choice>
-        <mc:Fallback>
+        <mc:Fallback xmlns="">
           <p:sp>
             <p:nvSpPr>
               <p:cNvPr id="53" name="TextBox 52">
@@ -10292,8 +10313,8 @@
           </a:p>
         </p:txBody>
       </p:sp>
-      <mc:AlternateContent xmlns:mc="http://schemas.openxmlformats.org/markup-compatibility/2006">
-        <mc:Choice xmlns:a14="http://schemas.microsoft.com/office/drawing/2010/main" Requires="a14">
+      <mc:AlternateContent xmlns:mc="http://schemas.openxmlformats.org/markup-compatibility/2006" xmlns:a14="http://schemas.microsoft.com/office/drawing/2010/main">
+        <mc:Choice Requires="a14">
           <p:sp>
             <p:nvSpPr>
               <p:cNvPr id="56" name="TextBox 55">
@@ -10474,7 +10495,7 @@
             </p:txBody>
           </p:sp>
         </mc:Choice>
-        <mc:Fallback>
+        <mc:Fallback xmlns="">
           <p:sp>
             <p:nvSpPr>
               <p:cNvPr id="56" name="TextBox 55">
@@ -10535,8 +10556,8 @@
             </p:nvSpPr>
             <p:spPr>
               <a:xfrm>
-                <a:off x="98727" y="1160601"/>
-                <a:ext cx="1129618" cy="356893"/>
+                <a:off x="98726" y="1160601"/>
+                <a:ext cx="1413081" cy="356893"/>
               </a:xfrm>
               <a:prstGeom prst="rect">
                 <a:avLst/>
@@ -10729,8 +10750,8 @@
             </p:nvSpPr>
             <p:spPr>
               <a:xfrm>
-                <a:off x="98727" y="1160601"/>
-                <a:ext cx="1129618" cy="356893"/>
+                <a:off x="98726" y="1160601"/>
+                <a:ext cx="1413081" cy="356893"/>
               </a:xfrm>
               <a:prstGeom prst="rect">
                 <a:avLst/>
@@ -10738,7 +10759,7 @@
               <a:blipFill>
                 <a:blip r:embed="rId6"/>
                 <a:stretch>
-                  <a:fillRect t="-3448" b="-6897"/>
+                  <a:fillRect t="-8475" r="-3448"/>
                 </a:stretch>
               </a:blipFill>
             </p:spPr>
@@ -10757,8 +10778,8 @@
           </p:sp>
         </mc:Fallback>
       </mc:AlternateContent>
-      <mc:AlternateContent xmlns:mc="http://schemas.openxmlformats.org/markup-compatibility/2006">
-        <mc:Choice xmlns:a14="http://schemas.microsoft.com/office/drawing/2010/main" Requires="a14">
+      <mc:AlternateContent xmlns:mc="http://schemas.openxmlformats.org/markup-compatibility/2006" xmlns:a14="http://schemas.microsoft.com/office/drawing/2010/main">
+        <mc:Choice Requires="a14">
           <p:sp>
             <p:nvSpPr>
               <p:cNvPr id="65" name="TextBox 64">
@@ -11072,7 +11093,7 @@
             </p:txBody>
           </p:sp>
         </mc:Choice>
-        <mc:Fallback>
+        <mc:Fallback xmlns="">
           <p:sp>
             <p:nvSpPr>
               <p:cNvPr id="65" name="TextBox 64">
@@ -11117,8 +11138,8 @@
           </p:sp>
         </mc:Fallback>
       </mc:AlternateContent>
-      <mc:AlternateContent xmlns:mc="http://schemas.openxmlformats.org/markup-compatibility/2006">
-        <mc:Choice xmlns:a14="http://schemas.microsoft.com/office/drawing/2010/main" Requires="a14">
+      <mc:AlternateContent xmlns:mc="http://schemas.openxmlformats.org/markup-compatibility/2006" xmlns:a14="http://schemas.microsoft.com/office/drawing/2010/main">
+        <mc:Choice Requires="a14">
           <p:sp>
             <p:nvSpPr>
               <p:cNvPr id="66" name="TextBox 65">
@@ -11186,7 +11207,7 @@
             </p:txBody>
           </p:sp>
         </mc:Choice>
-        <mc:Fallback>
+        <mc:Fallback xmlns="">
           <p:sp>
             <p:nvSpPr>
               <p:cNvPr id="66" name="TextBox 65">
@@ -11231,8 +11252,8 @@
           </p:sp>
         </mc:Fallback>
       </mc:AlternateContent>
-      <mc:AlternateContent xmlns:mc="http://schemas.openxmlformats.org/markup-compatibility/2006">
-        <mc:Choice xmlns:a14="http://schemas.microsoft.com/office/drawing/2010/main" Requires="a14">
+      <mc:AlternateContent xmlns:mc="http://schemas.openxmlformats.org/markup-compatibility/2006" xmlns:a14="http://schemas.microsoft.com/office/drawing/2010/main">
+        <mc:Choice Requires="a14">
           <p:sp>
             <p:nvSpPr>
               <p:cNvPr id="67" name="TextBox 66">
@@ -11304,7 +11325,7 @@
             </p:txBody>
           </p:sp>
         </mc:Choice>
-        <mc:Fallback>
+        <mc:Fallback xmlns="">
           <p:sp>
             <p:nvSpPr>
               <p:cNvPr id="67" name="TextBox 66">
@@ -11349,8 +11370,8 @@
           </p:sp>
         </mc:Fallback>
       </mc:AlternateContent>
-      <mc:AlternateContent xmlns:mc="http://schemas.openxmlformats.org/markup-compatibility/2006">
-        <mc:Choice xmlns:a14="http://schemas.microsoft.com/office/drawing/2010/main" Requires="a14">
+      <mc:AlternateContent xmlns:mc="http://schemas.openxmlformats.org/markup-compatibility/2006" xmlns:a14="http://schemas.microsoft.com/office/drawing/2010/main">
+        <mc:Choice Requires="a14">
           <p:sp>
             <p:nvSpPr>
               <p:cNvPr id="68" name="TextBox 67">
@@ -11418,7 +11439,7 @@
             </p:txBody>
           </p:sp>
         </mc:Choice>
-        <mc:Fallback>
+        <mc:Fallback xmlns="">
           <p:sp>
             <p:nvSpPr>
               <p:cNvPr id="68" name="TextBox 67">
@@ -11463,8 +11484,8 @@
           </p:sp>
         </mc:Fallback>
       </mc:AlternateContent>
-      <mc:AlternateContent xmlns:mc="http://schemas.openxmlformats.org/markup-compatibility/2006">
-        <mc:Choice xmlns:a14="http://schemas.microsoft.com/office/drawing/2010/main" Requires="a14">
+      <mc:AlternateContent xmlns:mc="http://schemas.openxmlformats.org/markup-compatibility/2006" xmlns:a14="http://schemas.microsoft.com/office/drawing/2010/main">
+        <mc:Choice Requires="a14">
           <p:sp>
             <p:nvSpPr>
               <p:cNvPr id="69" name="TextBox 68">
@@ -11536,7 +11557,7 @@
             </p:txBody>
           </p:sp>
         </mc:Choice>
-        <mc:Fallback>
+        <mc:Fallback xmlns="">
           <p:sp>
             <p:nvSpPr>
               <p:cNvPr id="69" name="TextBox 68">
@@ -11667,8 +11688,8 @@
           </a:fontRef>
         </p:style>
       </p:cxnSp>
-      <mc:AlternateContent xmlns:mc="http://schemas.openxmlformats.org/markup-compatibility/2006">
-        <mc:Choice xmlns:a14="http://schemas.microsoft.com/office/drawing/2010/main" Requires="a14">
+      <mc:AlternateContent xmlns:mc="http://schemas.openxmlformats.org/markup-compatibility/2006" xmlns:a14="http://schemas.microsoft.com/office/drawing/2010/main">
+        <mc:Choice Requires="a14">
           <p:sp>
             <p:nvSpPr>
               <p:cNvPr id="85" name="TextBox 84">
@@ -11779,7 +11800,7 @@
             </p:txBody>
           </p:sp>
         </mc:Choice>
-        <mc:Fallback>
+        <mc:Fallback xmlns="">
           <p:sp>
             <p:nvSpPr>
               <p:cNvPr id="85" name="TextBox 84">
@@ -11824,8 +11845,8 @@
           </p:sp>
         </mc:Fallback>
       </mc:AlternateContent>
-      <mc:AlternateContent xmlns:mc="http://schemas.openxmlformats.org/markup-compatibility/2006">
-        <mc:Choice xmlns:a14="http://schemas.microsoft.com/office/drawing/2010/main" Requires="a14">
+      <mc:AlternateContent xmlns:mc="http://schemas.openxmlformats.org/markup-compatibility/2006" xmlns:a14="http://schemas.microsoft.com/office/drawing/2010/main">
+        <mc:Choice Requires="a14">
           <p:sp>
             <p:nvSpPr>
               <p:cNvPr id="89" name="TextBox 88">
@@ -11854,6 +11875,7 @@
               </a:bodyPr>
               <a:lstStyle/>
               <a:p>
+                <a:pPr/>
                 <a14:m>
                   <m:oMathPara xmlns:m="http://schemas.openxmlformats.org/officeDocument/2006/math">
                     <m:oMathParaPr>
@@ -12282,7 +12304,7 @@
             </p:txBody>
           </p:sp>
         </mc:Choice>
-        <mc:Fallback>
+        <mc:Fallback xmlns="">
           <p:sp>
             <p:nvSpPr>
               <p:cNvPr id="89" name="TextBox 88">
@@ -12483,7 +12505,7 @@
             <p:spPr>
               <a:xfrm>
                 <a:off x="98726" y="2626168"/>
-                <a:ext cx="2168042" cy="552844"/>
+                <a:ext cx="2702410" cy="552844"/>
               </a:xfrm>
               <a:prstGeom prst="rect">
                 <a:avLst/>
@@ -12741,7 +12763,7 @@
             <p:spPr>
               <a:xfrm>
                 <a:off x="98726" y="2626168"/>
-                <a:ext cx="2168042" cy="552844"/>
+                <a:ext cx="2702410" cy="552844"/>
               </a:xfrm>
               <a:prstGeom prst="rect">
                 <a:avLst/>
@@ -12749,7 +12771,7 @@
               <a:blipFill>
                 <a:blip r:embed="rId14"/>
                 <a:stretch>
-                  <a:fillRect t="-4444" b="-2222"/>
+                  <a:fillRect/>
                 </a:stretch>
               </a:blipFill>
             </p:spPr>
@@ -12784,8 +12806,8 @@
             </p:nvSpPr>
             <p:spPr>
               <a:xfrm>
-                <a:off x="102080" y="3216536"/>
-                <a:ext cx="3994535" cy="651076"/>
+                <a:off x="10211" y="3225351"/>
+                <a:ext cx="4120468" cy="651076"/>
               </a:xfrm>
               <a:prstGeom prst="rect">
                 <a:avLst/>
@@ -13152,8 +13174,8 @@
             </p:nvSpPr>
             <p:spPr>
               <a:xfrm>
-                <a:off x="102080" y="3216536"/>
-                <a:ext cx="3994535" cy="651076"/>
+                <a:off x="10211" y="3225351"/>
+                <a:ext cx="4120468" cy="651076"/>
               </a:xfrm>
               <a:prstGeom prst="rect">
                 <a:avLst/>
@@ -13161,7 +13183,7 @@
               <a:blipFill>
                 <a:blip r:embed="rId15"/>
                 <a:stretch>
-                  <a:fillRect t="-1923"/>
+                  <a:fillRect/>
                 </a:stretch>
               </a:blipFill>
             </p:spPr>
@@ -13268,8 +13290,8 @@
           </a:fontRef>
         </p:style>
       </p:cxnSp>
-      <mc:AlternateContent xmlns:mc="http://schemas.openxmlformats.org/markup-compatibility/2006">
-        <mc:Choice xmlns:a14="http://schemas.microsoft.com/office/drawing/2010/main" Requires="a14">
+      <mc:AlternateContent xmlns:mc="http://schemas.openxmlformats.org/markup-compatibility/2006" xmlns:a14="http://schemas.microsoft.com/office/drawing/2010/main">
+        <mc:Choice Requires="a14">
           <p:sp>
             <p:nvSpPr>
               <p:cNvPr id="108" name="TextBox 107">
@@ -13337,7 +13359,7 @@
             </p:txBody>
           </p:sp>
         </mc:Choice>
-        <mc:Fallback>
+        <mc:Fallback xmlns="">
           <p:sp>
             <p:nvSpPr>
               <p:cNvPr id="108" name="TextBox 107">
@@ -13382,8 +13404,8 @@
           </p:sp>
         </mc:Fallback>
       </mc:AlternateContent>
-      <mc:AlternateContent xmlns:mc="http://schemas.openxmlformats.org/markup-compatibility/2006">
-        <mc:Choice xmlns:a14="http://schemas.microsoft.com/office/drawing/2010/main" Requires="a14">
+      <mc:AlternateContent xmlns:mc="http://schemas.openxmlformats.org/markup-compatibility/2006" xmlns:a14="http://schemas.microsoft.com/office/drawing/2010/main">
+        <mc:Choice Requires="a14">
           <p:sp>
             <p:nvSpPr>
               <p:cNvPr id="110" name="TextBox 109">
@@ -13709,7 +13731,7 @@
             </p:txBody>
           </p:sp>
         </mc:Choice>
-        <mc:Fallback>
+        <mc:Fallback xmlns="">
           <p:sp>
             <p:nvSpPr>
               <p:cNvPr id="110" name="TextBox 109">
@@ -13902,8 +13924,8 @@
           </a:fontRef>
         </p:style>
       </p:cxnSp>
-      <mc:AlternateContent xmlns:mc="http://schemas.openxmlformats.org/markup-compatibility/2006">
-        <mc:Choice xmlns:a14="http://schemas.microsoft.com/office/drawing/2010/main" Requires="a14">
+      <mc:AlternateContent xmlns:mc="http://schemas.openxmlformats.org/markup-compatibility/2006" xmlns:a14="http://schemas.microsoft.com/office/drawing/2010/main">
+        <mc:Choice Requires="a14">
           <p:sp>
             <p:nvSpPr>
               <p:cNvPr id="116" name="TextBox 115">
@@ -14003,7 +14025,7 @@
             </p:txBody>
           </p:sp>
         </mc:Choice>
-        <mc:Fallback>
+        <mc:Fallback xmlns="">
           <p:sp>
             <p:nvSpPr>
               <p:cNvPr id="116" name="TextBox 115">
@@ -14133,8 +14155,8 @@
           </a:fontRef>
         </p:style>
       </p:cxnSp>
-      <mc:AlternateContent xmlns:mc="http://schemas.openxmlformats.org/markup-compatibility/2006">
-        <mc:Choice xmlns:a14="http://schemas.microsoft.com/office/drawing/2010/main" Requires="a14">
+      <mc:AlternateContent xmlns:mc="http://schemas.openxmlformats.org/markup-compatibility/2006" xmlns:a14="http://schemas.microsoft.com/office/drawing/2010/main">
+        <mc:Choice Requires="a14">
           <p:sp>
             <p:nvSpPr>
               <p:cNvPr id="126" name="TextBox 125">
@@ -14202,7 +14224,7 @@
             </p:txBody>
           </p:sp>
         </mc:Choice>
-        <mc:Fallback>
+        <mc:Fallback xmlns="">
           <p:sp>
             <p:nvSpPr>
               <p:cNvPr id="126" name="TextBox 125">
@@ -14247,8 +14269,8 @@
           </p:sp>
         </mc:Fallback>
       </mc:AlternateContent>
-      <mc:AlternateContent xmlns:mc="http://schemas.openxmlformats.org/markup-compatibility/2006">
-        <mc:Choice xmlns:a14="http://schemas.microsoft.com/office/drawing/2010/main" Requires="a14">
+      <mc:AlternateContent xmlns:mc="http://schemas.openxmlformats.org/markup-compatibility/2006" xmlns:a14="http://schemas.microsoft.com/office/drawing/2010/main">
+        <mc:Choice Requires="a14">
           <p:sp>
             <p:nvSpPr>
               <p:cNvPr id="127" name="TextBox 126">
@@ -14320,7 +14342,7 @@
             </p:txBody>
           </p:sp>
         </mc:Choice>
-        <mc:Fallback>
+        <mc:Fallback xmlns="">
           <p:sp>
             <p:nvSpPr>
               <p:cNvPr id="127" name="TextBox 126">
@@ -14365,8 +14387,8 @@
           </p:sp>
         </mc:Fallback>
       </mc:AlternateContent>
-      <mc:AlternateContent xmlns:mc="http://schemas.openxmlformats.org/markup-compatibility/2006">
-        <mc:Choice xmlns:a14="http://schemas.microsoft.com/office/drawing/2010/main" Requires="a14">
+      <mc:AlternateContent xmlns:mc="http://schemas.openxmlformats.org/markup-compatibility/2006" xmlns:a14="http://schemas.microsoft.com/office/drawing/2010/main">
+        <mc:Choice Requires="a14">
           <p:sp>
             <p:nvSpPr>
               <p:cNvPr id="130" name="TextBox 129">
@@ -14634,7 +14656,7 @@
             </p:txBody>
           </p:sp>
         </mc:Choice>
-        <mc:Fallback>
+        <mc:Fallback xmlns="">
           <p:sp>
             <p:nvSpPr>
               <p:cNvPr id="130" name="TextBox 129">
@@ -15386,8 +15408,8 @@
           </a:fontRef>
         </p:style>
       </p:cxnSp>
-      <mc:AlternateContent xmlns:mc="http://schemas.openxmlformats.org/markup-compatibility/2006">
-        <mc:Choice xmlns:a14="http://schemas.microsoft.com/office/drawing/2010/main" Requires="a14">
+      <mc:AlternateContent xmlns:mc="http://schemas.openxmlformats.org/markup-compatibility/2006" xmlns:a14="http://schemas.microsoft.com/office/drawing/2010/main">
+        <mc:Choice Requires="a14">
           <p:sp>
             <p:nvSpPr>
               <p:cNvPr id="17" name="TextBox 16">
@@ -15416,6 +15438,7 @@
               </a:bodyPr>
               <a:lstStyle/>
               <a:p>
+                <a:pPr/>
                 <a14:m>
                   <m:oMathPara xmlns:m="http://schemas.openxmlformats.org/officeDocument/2006/math">
                     <m:oMathParaPr>
@@ -15486,7 +15509,7 @@
             </p:txBody>
           </p:sp>
         </mc:Choice>
-        <mc:Fallback>
+        <mc:Fallback xmlns="">
           <p:sp>
             <p:nvSpPr>
               <p:cNvPr id="17" name="TextBox 16">
@@ -15619,8 +15642,8 @@
           </a:fontRef>
         </p:style>
       </p:cxnSp>
-      <mc:AlternateContent xmlns:mc="http://schemas.openxmlformats.org/markup-compatibility/2006">
-        <mc:Choice xmlns:a14="http://schemas.microsoft.com/office/drawing/2010/main" Requires="a14">
+      <mc:AlternateContent xmlns:mc="http://schemas.openxmlformats.org/markup-compatibility/2006" xmlns:a14="http://schemas.microsoft.com/office/drawing/2010/main">
+        <mc:Choice Requires="a14">
           <p:sp>
             <p:nvSpPr>
               <p:cNvPr id="20" name="TextBox 19">
@@ -15649,6 +15672,7 @@
               </a:bodyPr>
               <a:lstStyle/>
               <a:p>
+                <a:pPr/>
                 <a14:m>
                   <m:oMathPara xmlns:m="http://schemas.openxmlformats.org/officeDocument/2006/math">
                     <m:oMathParaPr>
@@ -15687,7 +15711,7 @@
             </p:txBody>
           </p:sp>
         </mc:Choice>
-        <mc:Fallback>
+        <mc:Fallback xmlns="">
           <p:sp>
             <p:nvSpPr>
               <p:cNvPr id="20" name="TextBox 19">
@@ -15732,8 +15756,8 @@
           </p:sp>
         </mc:Fallback>
       </mc:AlternateContent>
-      <mc:AlternateContent xmlns:mc="http://schemas.openxmlformats.org/markup-compatibility/2006">
-        <mc:Choice xmlns:a14="http://schemas.microsoft.com/office/drawing/2010/main" Requires="a14">
+      <mc:AlternateContent xmlns:mc="http://schemas.openxmlformats.org/markup-compatibility/2006" xmlns:a14="http://schemas.microsoft.com/office/drawing/2010/main">
+        <mc:Choice Requires="a14">
           <p:sp>
             <p:nvSpPr>
               <p:cNvPr id="21" name="TextBox 20">
@@ -15791,7 +15815,7 @@
             </p:txBody>
           </p:sp>
         </mc:Choice>
-        <mc:Fallback>
+        <mc:Fallback xmlns="">
           <p:sp>
             <p:nvSpPr>
               <p:cNvPr id="21" name="TextBox 20">
@@ -15872,8 +15896,8 @@
           </a:p>
         </p:txBody>
       </p:sp>
-      <mc:AlternateContent xmlns:mc="http://schemas.openxmlformats.org/markup-compatibility/2006">
-        <mc:Choice xmlns:a14="http://schemas.microsoft.com/office/drawing/2010/main" Requires="a14">
+      <mc:AlternateContent xmlns:mc="http://schemas.openxmlformats.org/markup-compatibility/2006" xmlns:a14="http://schemas.microsoft.com/office/drawing/2010/main">
+        <mc:Choice Requires="a14">
           <p:sp>
             <p:nvSpPr>
               <p:cNvPr id="26" name="TextBox 25">
@@ -15902,6 +15926,7 @@
               </a:bodyPr>
               <a:lstStyle/>
               <a:p>
+                <a:pPr/>
                 <a14:m>
                   <m:oMathPara xmlns:m="http://schemas.openxmlformats.org/officeDocument/2006/math">
                     <m:oMathParaPr>
@@ -15940,7 +15965,7 @@
             </p:txBody>
           </p:sp>
         </mc:Choice>
-        <mc:Fallback>
+        <mc:Fallback xmlns="">
           <p:sp>
             <p:nvSpPr>
               <p:cNvPr id="26" name="TextBox 25">
@@ -15985,8 +16010,8 @@
           </p:sp>
         </mc:Fallback>
       </mc:AlternateContent>
-      <mc:AlternateContent xmlns:mc="http://schemas.openxmlformats.org/markup-compatibility/2006">
-        <mc:Choice xmlns:a14="http://schemas.microsoft.com/office/drawing/2010/main" Requires="a14">
+      <mc:AlternateContent xmlns:mc="http://schemas.openxmlformats.org/markup-compatibility/2006" xmlns:a14="http://schemas.microsoft.com/office/drawing/2010/main">
+        <mc:Choice Requires="a14">
           <p:sp>
             <p:nvSpPr>
               <p:cNvPr id="27" name="TextBox 26">
@@ -16015,6 +16040,7 @@
               </a:bodyPr>
               <a:lstStyle/>
               <a:p>
+                <a:pPr/>
                 <a14:m>
                   <m:oMathPara xmlns:m="http://schemas.openxmlformats.org/officeDocument/2006/math">
                     <m:oMathParaPr>
@@ -16057,7 +16083,7 @@
             </p:txBody>
           </p:sp>
         </mc:Choice>
-        <mc:Fallback>
+        <mc:Fallback xmlns="">
           <p:sp>
             <p:nvSpPr>
               <p:cNvPr id="27" name="TextBox 26">
@@ -16102,8 +16128,8 @@
           </p:sp>
         </mc:Fallback>
       </mc:AlternateContent>
-      <mc:AlternateContent xmlns:mc="http://schemas.openxmlformats.org/markup-compatibility/2006">
-        <mc:Choice xmlns:a14="http://schemas.microsoft.com/office/drawing/2010/main" Requires="a14">
+      <mc:AlternateContent xmlns:mc="http://schemas.openxmlformats.org/markup-compatibility/2006" xmlns:a14="http://schemas.microsoft.com/office/drawing/2010/main">
+        <mc:Choice Requires="a14">
           <p:sp>
             <p:nvSpPr>
               <p:cNvPr id="28" name="TextBox 27">
@@ -16132,6 +16158,7 @@
               </a:bodyPr>
               <a:lstStyle/>
               <a:p>
+                <a:pPr/>
                 <a14:m>
                   <m:oMathPara xmlns:m="http://schemas.openxmlformats.org/officeDocument/2006/math">
                     <m:oMathParaPr>
@@ -16170,7 +16197,7 @@
             </p:txBody>
           </p:sp>
         </mc:Choice>
-        <mc:Fallback>
+        <mc:Fallback xmlns="">
           <p:sp>
             <p:nvSpPr>
               <p:cNvPr id="28" name="TextBox 27">
@@ -16215,8 +16242,8 @@
           </p:sp>
         </mc:Fallback>
       </mc:AlternateContent>
-      <mc:AlternateContent xmlns:mc="http://schemas.openxmlformats.org/markup-compatibility/2006">
-        <mc:Choice xmlns:a14="http://schemas.microsoft.com/office/drawing/2010/main" Requires="a14">
+      <mc:AlternateContent xmlns:mc="http://schemas.openxmlformats.org/markup-compatibility/2006" xmlns:a14="http://schemas.microsoft.com/office/drawing/2010/main">
+        <mc:Choice Requires="a14">
           <p:sp>
             <p:nvSpPr>
               <p:cNvPr id="29" name="TextBox 28">
@@ -16245,6 +16272,7 @@
               </a:bodyPr>
               <a:lstStyle/>
               <a:p>
+                <a:pPr/>
                 <a14:m>
                   <m:oMathPara xmlns:m="http://schemas.openxmlformats.org/officeDocument/2006/math">
                     <m:oMathParaPr>
@@ -16287,7 +16315,7 @@
             </p:txBody>
           </p:sp>
         </mc:Choice>
-        <mc:Fallback>
+        <mc:Fallback xmlns="">
           <p:sp>
             <p:nvSpPr>
               <p:cNvPr id="29" name="TextBox 28">
@@ -16373,8 +16401,8 @@
           </a:fontRef>
         </p:style>
       </p:cxnSp>
-      <mc:AlternateContent xmlns:mc="http://schemas.openxmlformats.org/markup-compatibility/2006">
-        <mc:Choice xmlns:a14="http://schemas.microsoft.com/office/drawing/2010/main" Requires="a14">
+      <mc:AlternateContent xmlns:mc="http://schemas.openxmlformats.org/markup-compatibility/2006" xmlns:a14="http://schemas.microsoft.com/office/drawing/2010/main">
+        <mc:Choice Requires="a14">
           <p:sp>
             <p:nvSpPr>
               <p:cNvPr id="33" name="TextBox 32">
@@ -16703,7 +16731,7 @@
             </p:txBody>
           </p:sp>
         </mc:Choice>
-        <mc:Fallback>
+        <mc:Fallback xmlns="">
           <p:sp>
             <p:nvSpPr>
               <p:cNvPr id="33" name="TextBox 32">
@@ -16887,8 +16915,8 @@
           </a:p>
         </p:txBody>
       </p:sp>
-      <mc:AlternateContent xmlns:mc="http://schemas.openxmlformats.org/markup-compatibility/2006">
-        <mc:Choice xmlns:a14="http://schemas.microsoft.com/office/drawing/2010/main" Requires="a14">
+      <mc:AlternateContent xmlns:mc="http://schemas.openxmlformats.org/markup-compatibility/2006" xmlns:a14="http://schemas.microsoft.com/office/drawing/2010/main">
+        <mc:Choice Requires="a14">
           <p:sp>
             <p:nvSpPr>
               <p:cNvPr id="37" name="TextBox 36">
@@ -17081,7 +17109,7 @@
             </p:txBody>
           </p:sp>
         </mc:Choice>
-        <mc:Fallback>
+        <mc:Fallback xmlns="">
           <p:sp>
             <p:nvSpPr>
               <p:cNvPr id="37" name="TextBox 36">
@@ -17126,8 +17154,8 @@
           </p:sp>
         </mc:Fallback>
       </mc:AlternateContent>
-      <mc:AlternateContent xmlns:mc="http://schemas.openxmlformats.org/markup-compatibility/2006">
-        <mc:Choice xmlns:a14="http://schemas.microsoft.com/office/drawing/2010/main" Requires="a14">
+      <mc:AlternateContent xmlns:mc="http://schemas.openxmlformats.org/markup-compatibility/2006" xmlns:a14="http://schemas.microsoft.com/office/drawing/2010/main">
+        <mc:Choice Requires="a14">
           <p:sp>
             <p:nvSpPr>
               <p:cNvPr id="38" name="TextBox 37">
@@ -17493,7 +17521,7 @@
             </p:txBody>
           </p:sp>
         </mc:Choice>
-        <mc:Fallback>
+        <mc:Fallback xmlns="">
           <p:sp>
             <p:nvSpPr>
               <p:cNvPr id="38" name="TextBox 37">
@@ -17626,8 +17654,8 @@
           </a:fontRef>
         </p:style>
       </p:cxnSp>
-      <mc:AlternateContent xmlns:mc="http://schemas.openxmlformats.org/markup-compatibility/2006">
-        <mc:Choice xmlns:a14="http://schemas.microsoft.com/office/drawing/2010/main" Requires="a14">
+      <mc:AlternateContent xmlns:mc="http://schemas.openxmlformats.org/markup-compatibility/2006" xmlns:a14="http://schemas.microsoft.com/office/drawing/2010/main">
+        <mc:Choice Requires="a14">
           <p:sp>
             <p:nvSpPr>
               <p:cNvPr id="41" name="TextBox 40">
@@ -17695,7 +17723,7 @@
             </p:txBody>
           </p:sp>
         </mc:Choice>
-        <mc:Fallback>
+        <mc:Fallback xmlns="">
           <p:sp>
             <p:nvSpPr>
               <p:cNvPr id="41" name="TextBox 40">
@@ -17740,8 +17768,8 @@
           </p:sp>
         </mc:Fallback>
       </mc:AlternateContent>
-      <mc:AlternateContent xmlns:mc="http://schemas.openxmlformats.org/markup-compatibility/2006">
-        <mc:Choice xmlns:a14="http://schemas.microsoft.com/office/drawing/2010/main" Requires="a14">
+      <mc:AlternateContent xmlns:mc="http://schemas.openxmlformats.org/markup-compatibility/2006" xmlns:a14="http://schemas.microsoft.com/office/drawing/2010/main">
+        <mc:Choice Requires="a14">
           <p:sp>
             <p:nvSpPr>
               <p:cNvPr id="42" name="TextBox 41">
@@ -17770,7 +17798,6 @@
               </a:bodyPr>
               <a:lstStyle/>
               <a:p>
-                <a:pPr/>
                 <a14:m>
                   <m:oMath xmlns:m="http://schemas.openxmlformats.org/officeDocument/2006/math">
                     <m:sSubSup>
@@ -18065,7 +18092,7 @@
             </p:txBody>
           </p:sp>
         </mc:Choice>
-        <mc:Fallback>
+        <mc:Fallback xmlns="">
           <p:sp>
             <p:nvSpPr>
               <p:cNvPr id="42" name="TextBox 41">
@@ -18258,8 +18285,8 @@
           </a:fontRef>
         </p:style>
       </p:cxnSp>
-      <mc:AlternateContent xmlns:mc="http://schemas.openxmlformats.org/markup-compatibility/2006">
-        <mc:Choice xmlns:a14="http://schemas.microsoft.com/office/drawing/2010/main" Requires="a14">
+      <mc:AlternateContent xmlns:mc="http://schemas.openxmlformats.org/markup-compatibility/2006" xmlns:a14="http://schemas.microsoft.com/office/drawing/2010/main">
+        <mc:Choice Requires="a14">
           <p:sp>
             <p:nvSpPr>
               <p:cNvPr id="46" name="TextBox 45">
@@ -18359,7 +18386,7 @@
             </p:txBody>
           </p:sp>
         </mc:Choice>
-        <mc:Fallback>
+        <mc:Fallback xmlns="">
           <p:sp>
             <p:nvSpPr>
               <p:cNvPr id="46" name="TextBox 45">
@@ -18489,8 +18516,8 @@
           </a:fontRef>
         </p:style>
       </p:cxnSp>
-      <mc:AlternateContent xmlns:mc="http://schemas.openxmlformats.org/markup-compatibility/2006">
-        <mc:Choice xmlns:a14="http://schemas.microsoft.com/office/drawing/2010/main" Requires="a14">
+      <mc:AlternateContent xmlns:mc="http://schemas.openxmlformats.org/markup-compatibility/2006" xmlns:a14="http://schemas.microsoft.com/office/drawing/2010/main">
+        <mc:Choice Requires="a14">
           <p:sp>
             <p:nvSpPr>
               <p:cNvPr id="49" name="TextBox 48">
@@ -18519,6 +18546,7 @@
               </a:bodyPr>
               <a:lstStyle/>
               <a:p>
+                <a:pPr/>
                 <a14:m>
                   <m:oMathPara xmlns:m="http://schemas.openxmlformats.org/officeDocument/2006/math">
                     <m:oMathParaPr>
@@ -18557,7 +18585,7 @@
             </p:txBody>
           </p:sp>
         </mc:Choice>
-        <mc:Fallback>
+        <mc:Fallback xmlns="">
           <p:sp>
             <p:nvSpPr>
               <p:cNvPr id="49" name="TextBox 48">
@@ -18602,8 +18630,8 @@
           </p:sp>
         </mc:Fallback>
       </mc:AlternateContent>
-      <mc:AlternateContent xmlns:mc="http://schemas.openxmlformats.org/markup-compatibility/2006">
-        <mc:Choice xmlns:a14="http://schemas.microsoft.com/office/drawing/2010/main" Requires="a14">
+      <mc:AlternateContent xmlns:mc="http://schemas.openxmlformats.org/markup-compatibility/2006" xmlns:a14="http://schemas.microsoft.com/office/drawing/2010/main">
+        <mc:Choice Requires="a14">
           <p:sp>
             <p:nvSpPr>
               <p:cNvPr id="50" name="TextBox 49">
@@ -18632,6 +18660,7 @@
               </a:bodyPr>
               <a:lstStyle/>
               <a:p>
+                <a:pPr/>
                 <a14:m>
                   <m:oMathPara xmlns:m="http://schemas.openxmlformats.org/officeDocument/2006/math">
                     <m:oMathParaPr>
@@ -18674,7 +18703,7 @@
             </p:txBody>
           </p:sp>
         </mc:Choice>
-        <mc:Fallback>
+        <mc:Fallback xmlns="">
           <p:sp>
             <p:nvSpPr>
               <p:cNvPr id="50" name="TextBox 49">
@@ -18749,7 +18778,6 @@
               </a:bodyPr>
               <a:lstStyle/>
               <a:p>
-                <a:pPr/>
                 <a14:m>
                   <m:oMath xmlns:m="http://schemas.openxmlformats.org/officeDocument/2006/math">
                     <m:sSubSup>
@@ -18987,7 +19015,7 @@
               <a:blipFill>
                 <a:blip r:embed="rId17"/>
                 <a:stretch>
-                  <a:fillRect b="-3030"/>
+                  <a:fillRect/>
                 </a:stretch>
               </a:blipFill>
             </p:spPr>
@@ -19148,8 +19176,8 @@
           </a:p>
         </p:txBody>
       </p:sp>
-      <mc:AlternateContent xmlns:mc="http://schemas.openxmlformats.org/markup-compatibility/2006">
-        <mc:Choice xmlns:a14="http://schemas.microsoft.com/office/drawing/2010/main" Requires="a14">
+      <mc:AlternateContent xmlns:mc="http://schemas.openxmlformats.org/markup-compatibility/2006" xmlns:a14="http://schemas.microsoft.com/office/drawing/2010/main">
+        <mc:Choice Requires="a14">
           <p:sp>
             <p:nvSpPr>
               <p:cNvPr id="55" name="TextBox 54">
@@ -19178,6 +19206,7 @@
               </a:bodyPr>
               <a:lstStyle/>
               <a:p>
+                <a:pPr/>
                 <a14:m>
                   <m:oMathPara xmlns:m="http://schemas.openxmlformats.org/officeDocument/2006/math">
                     <m:oMathParaPr>
@@ -19187,7 +19216,7 @@
                       <m:sSubSup>
                         <m:sSubSupPr>
                           <m:ctrlPr>
-                            <a:rPr lang="ru-RU" sz="1400" smtClean="0">
+                            <a:rPr lang="ru-RU" sz="1400" i="1" smtClean="0">
                               <a:latin typeface="Cambria Math" panose="02040503050406030204" pitchFamily="18" charset="0"/>
                             </a:rPr>
                           </m:ctrlPr>
@@ -19332,7 +19361,7 @@
             </p:txBody>
           </p:sp>
         </mc:Choice>
-        <mc:Fallback>
+        <mc:Fallback xmlns="">
           <p:sp>
             <p:nvSpPr>
               <p:cNvPr id="55" name="TextBox 54">
@@ -19377,8 +19406,8 @@
           </p:sp>
         </mc:Fallback>
       </mc:AlternateContent>
-      <mc:AlternateContent xmlns:mc="http://schemas.openxmlformats.org/markup-compatibility/2006">
-        <mc:Choice xmlns:a14="http://schemas.microsoft.com/office/drawing/2010/main" Requires="a14">
+      <mc:AlternateContent xmlns:mc="http://schemas.openxmlformats.org/markup-compatibility/2006" xmlns:a14="http://schemas.microsoft.com/office/drawing/2010/main">
+        <mc:Choice Requires="a14">
           <p:sp>
             <p:nvSpPr>
               <p:cNvPr id="57" name="TextBox 56">
@@ -19407,6 +19436,7 @@
               </a:bodyPr>
               <a:lstStyle/>
               <a:p>
+                <a:pPr/>
                 <a14:m>
                   <m:oMathPara xmlns:m="http://schemas.openxmlformats.org/officeDocument/2006/math">
                     <m:oMathParaPr>
@@ -19503,7 +19533,7 @@
             </p:txBody>
           </p:sp>
         </mc:Choice>
-        <mc:Fallback>
+        <mc:Fallback xmlns="">
           <p:sp>
             <p:nvSpPr>
               <p:cNvPr id="57" name="TextBox 56">

</xml_diff>